<commit_message>
merged input from Paolo
</commit_message>
<xml_diff>
--- a/125/NMOP/draft-netana-nmop-message-broker-bmp-telemetry-msg-02.pptx
+++ b/125/NMOP/draft-netana-nmop-message-broker-bmp-telemetry-msg-02.pptx
@@ -18,8 +18,8 @@
     <p:sldId id="2145706280" r:id="rId9"/>
     <p:sldId id="2145706295" r:id="rId10"/>
     <p:sldId id="2145706296" r:id="rId11"/>
-    <p:sldId id="2145706302" r:id="rId12"/>
-    <p:sldId id="2145706303" r:id="rId13"/>
+    <p:sldId id="2145706303" r:id="rId12"/>
+    <p:sldId id="2145706302" r:id="rId13"/>
     <p:sldId id="2145706297" r:id="rId14"/>
     <p:sldId id="2145706298" r:id="rId15"/>
     <p:sldId id="2145706304" r:id="rId16"/>
@@ -618,12 +618,12 @@
   <pc:docChgLst>
     <pc:chgData name="Graf Thomas, SCS-INI-NET-VNC-E2E" userId="487bc3e3-9ce7-4cdd-b7b4-8899ea88d289" providerId="ADAL" clId="{ADEEF08A-D719-4B50-A383-4105EDA2C206}"/>
     <pc:docChg chg="undo redo custSel addSld delSld modSld sldOrd">
-      <pc:chgData name="Graf Thomas, SCS-INI-NET-VNC-E2E" userId="487bc3e3-9ce7-4cdd-b7b4-8899ea88d289" providerId="ADAL" clId="{ADEEF08A-D719-4B50-A383-4105EDA2C206}" dt="2026-03-06T15:27:05.528" v="6106" actId="47"/>
+      <pc:chgData name="Graf Thomas, SCS-INI-NET-VNC-E2E" userId="487bc3e3-9ce7-4cdd-b7b4-8899ea88d289" providerId="ADAL" clId="{ADEEF08A-D719-4B50-A383-4105EDA2C206}" dt="2026-03-09T09:48:28.303" v="6111" actId="790"/>
       <pc:docMkLst>
         <pc:docMk/>
       </pc:docMkLst>
       <pc:sldChg chg="modSp mod">
-        <pc:chgData name="Graf Thomas, SCS-INI-NET-VNC-E2E" userId="487bc3e3-9ce7-4cdd-b7b4-8899ea88d289" providerId="ADAL" clId="{ADEEF08A-D719-4B50-A383-4105EDA2C206}" dt="2026-03-06T13:38:49.120" v="2017" actId="20577"/>
+        <pc:chgData name="Graf Thomas, SCS-INI-NET-VNC-E2E" userId="487bc3e3-9ce7-4cdd-b7b4-8899ea88d289" providerId="ADAL" clId="{ADEEF08A-D719-4B50-A383-4105EDA2C206}" dt="2026-03-09T09:47:44.699" v="6110" actId="20577"/>
         <pc:sldMkLst>
           <pc:docMk/>
           <pc:sldMk cId="3578665336" sldId="1041"/>
@@ -637,7 +637,7 @@
           </ac:spMkLst>
         </pc:spChg>
         <pc:spChg chg="mod">
-          <ac:chgData name="Graf Thomas, SCS-INI-NET-VNC-E2E" userId="487bc3e3-9ce7-4cdd-b7b4-8899ea88d289" providerId="ADAL" clId="{ADEEF08A-D719-4B50-A383-4105EDA2C206}" dt="2026-03-06T12:06:45.279" v="752" actId="20577"/>
+          <ac:chgData name="Graf Thomas, SCS-INI-NET-VNC-E2E" userId="487bc3e3-9ce7-4cdd-b7b4-8899ea88d289" providerId="ADAL" clId="{ADEEF08A-D719-4B50-A383-4105EDA2C206}" dt="2026-03-09T09:47:44.699" v="6110" actId="20577"/>
           <ac:spMkLst>
             <pc:docMk/>
             <pc:sldMk cId="3578665336" sldId="1041"/>
@@ -705,14 +705,6 @@
             <ac:spMk id="3" creationId="{E1C8AC62-B5C5-ADE4-1957-88D3A14E964A}"/>
           </ac:spMkLst>
         </pc:spChg>
-        <pc:spChg chg="del">
-          <ac:chgData name="Graf Thomas, SCS-INI-NET-VNC-E2E" userId="487bc3e3-9ce7-4cdd-b7b4-8899ea88d289" providerId="ADAL" clId="{ADEEF08A-D719-4B50-A383-4105EDA2C206}" dt="2026-03-06T15:16:15.987" v="6013" actId="478"/>
-          <ac:spMkLst>
-            <pc:docMk/>
-            <pc:sldMk cId="2750719351" sldId="2145706243"/>
-            <ac:spMk id="5" creationId="{8C23250E-A19C-6C6E-E1FC-F12B08950F9A}"/>
-          </ac:spMkLst>
-        </pc:spChg>
       </pc:sldChg>
       <pc:sldChg chg="addSp delSp modSp mod">
         <pc:chgData name="Graf Thomas, SCS-INI-NET-VNC-E2E" userId="487bc3e3-9ce7-4cdd-b7b4-8899ea88d289" providerId="ADAL" clId="{ADEEF08A-D719-4B50-A383-4105EDA2C206}" dt="2026-03-06T15:09:14.721" v="5916" actId="20577"/>
@@ -736,22 +728,6 @@
             <ac:spMk id="19" creationId="{56D79134-17A9-8BC8-B7D0-97BCFFB9A6B2}"/>
           </ac:spMkLst>
         </pc:spChg>
-        <pc:picChg chg="del">
-          <ac:chgData name="Graf Thomas, SCS-INI-NET-VNC-E2E" userId="487bc3e3-9ce7-4cdd-b7b4-8899ea88d289" providerId="ADAL" clId="{ADEEF08A-D719-4B50-A383-4105EDA2C206}" dt="2026-03-06T12:42:21.241" v="753" actId="478"/>
-          <ac:picMkLst>
-            <pc:docMk/>
-            <pc:sldMk cId="1315775908" sldId="2145706280"/>
-            <ac:picMk id="3" creationId="{67E48B25-B0E5-1389-9DDE-DC3F28D870D5}"/>
-          </ac:picMkLst>
-        </pc:picChg>
-        <pc:picChg chg="add del mod">
-          <ac:chgData name="Graf Thomas, SCS-INI-NET-VNC-E2E" userId="487bc3e3-9ce7-4cdd-b7b4-8899ea88d289" providerId="ADAL" clId="{ADEEF08A-D719-4B50-A383-4105EDA2C206}" dt="2026-03-06T12:52:33.781" v="1318" actId="478"/>
-          <ac:picMkLst>
-            <pc:docMk/>
-            <pc:sldMk cId="1315775908" sldId="2145706280"/>
-            <ac:picMk id="4" creationId="{72ACD639-DF8B-C67F-DEC7-EB8CED78B2EC}"/>
-          </ac:picMkLst>
-        </pc:picChg>
         <pc:picChg chg="add mod">
           <ac:chgData name="Graf Thomas, SCS-INI-NET-VNC-E2E" userId="487bc3e3-9ce7-4cdd-b7b4-8899ea88d289" providerId="ADAL" clId="{ADEEF08A-D719-4B50-A383-4105EDA2C206}" dt="2026-03-06T12:52:56.454" v="1325" actId="1076"/>
           <ac:picMkLst>
@@ -799,22 +775,6 @@
             <ac:picMk id="3" creationId="{A72A9F9C-6919-27FB-9676-4220EB0FB280}"/>
           </ac:picMkLst>
         </pc:picChg>
-        <pc:picChg chg="add del mod">
-          <ac:chgData name="Graf Thomas, SCS-INI-NET-VNC-E2E" userId="487bc3e3-9ce7-4cdd-b7b4-8899ea88d289" providerId="ADAL" clId="{ADEEF08A-D719-4B50-A383-4105EDA2C206}" dt="2026-03-06T12:58:53.297" v="1735" actId="478"/>
-          <ac:picMkLst>
-            <pc:docMk/>
-            <pc:sldMk cId="3685482022" sldId="2145706295"/>
-            <ac:picMk id="7" creationId="{F7CDFCCF-B28F-0B7E-9C82-3A7533A5784A}"/>
-          </ac:picMkLst>
-        </pc:picChg>
-        <pc:picChg chg="del">
-          <ac:chgData name="Graf Thomas, SCS-INI-NET-VNC-E2E" userId="487bc3e3-9ce7-4cdd-b7b4-8899ea88d289" providerId="ADAL" clId="{ADEEF08A-D719-4B50-A383-4105EDA2C206}" dt="2026-03-06T12:54:33.128" v="1370" actId="478"/>
-          <ac:picMkLst>
-            <pc:docMk/>
-            <pc:sldMk cId="3685482022" sldId="2145706295"/>
-            <ac:picMk id="12" creationId="{F48427E1-ECCE-9D41-9FBB-76438A11CB8D}"/>
-          </ac:picMkLst>
-        </pc:picChg>
       </pc:sldChg>
       <pc:sldChg chg="addSp delSp modSp mod">
         <pc:chgData name="Graf Thomas, SCS-INI-NET-VNC-E2E" userId="487bc3e3-9ce7-4cdd-b7b4-8899ea88d289" providerId="ADAL" clId="{ADEEF08A-D719-4B50-A383-4105EDA2C206}" dt="2026-03-06T13:02:18.885" v="1770" actId="20577"/>
@@ -836,14 +796,6 @@
             <pc:docMk/>
             <pc:sldMk cId="1475201924" sldId="2145706296"/>
             <ac:picMk id="3" creationId="{7FE1D9BE-38E0-66CE-DDC0-29019F670C04}"/>
-          </ac:picMkLst>
-        </pc:picChg>
-        <pc:picChg chg="del">
-          <ac:chgData name="Graf Thomas, SCS-INI-NET-VNC-E2E" userId="487bc3e3-9ce7-4cdd-b7b4-8899ea88d289" providerId="ADAL" clId="{ADEEF08A-D719-4B50-A383-4105EDA2C206}" dt="2026-03-06T13:01:21.147" v="1752" actId="478"/>
-          <ac:picMkLst>
-            <pc:docMk/>
-            <pc:sldMk cId="1475201924" sldId="2145706296"/>
-            <ac:picMk id="9" creationId="{D0B83582-6D09-7FE2-4322-FF2E46B60A3E}"/>
           </ac:picMkLst>
         </pc:picChg>
       </pc:sldChg>
@@ -869,14 +821,6 @@
             <ac:spMk id="19" creationId="{0F259462-CCD4-C4B0-D206-9BE4F9B2EC1C}"/>
           </ac:spMkLst>
         </pc:spChg>
-        <pc:picChg chg="del">
-          <ac:chgData name="Graf Thomas, SCS-INI-NET-VNC-E2E" userId="487bc3e3-9ce7-4cdd-b7b4-8899ea88d289" providerId="ADAL" clId="{ADEEF08A-D719-4B50-A383-4105EDA2C206}" dt="2026-03-06T13:04:02.220" v="1779" actId="478"/>
-          <ac:picMkLst>
-            <pc:docMk/>
-            <pc:sldMk cId="710783608" sldId="2145706297"/>
-            <ac:picMk id="3" creationId="{2286D54F-28C1-096E-701B-0EDE738BD9D2}"/>
-          </ac:picMkLst>
-        </pc:picChg>
         <pc:picChg chg="add mod">
           <ac:chgData name="Graf Thomas, SCS-INI-NET-VNC-E2E" userId="487bc3e3-9ce7-4cdd-b7b4-8899ea88d289" providerId="ADAL" clId="{ADEEF08A-D719-4B50-A383-4105EDA2C206}" dt="2026-03-06T13:04:11.962" v="1783" actId="1076"/>
           <ac:picMkLst>
@@ -908,14 +852,6 @@
             <ac:spMk id="19" creationId="{1FB5448B-9146-4CF5-54FA-872A8BB2B5BC}"/>
           </ac:spMkLst>
         </pc:spChg>
-        <pc:picChg chg="del">
-          <ac:chgData name="Graf Thomas, SCS-INI-NET-VNC-E2E" userId="487bc3e3-9ce7-4cdd-b7b4-8899ea88d289" providerId="ADAL" clId="{ADEEF08A-D719-4B50-A383-4105EDA2C206}" dt="2026-03-06T13:06:23.953" v="1823" actId="478"/>
-          <ac:picMkLst>
-            <pc:docMk/>
-            <pc:sldMk cId="3625312977" sldId="2145706298"/>
-            <ac:picMk id="3" creationId="{E99BCB33-C892-431B-F8AF-15D7375C59BA}"/>
-          </ac:picMkLst>
-        </pc:picChg>
         <pc:picChg chg="add mod">
           <ac:chgData name="Graf Thomas, SCS-INI-NET-VNC-E2E" userId="487bc3e3-9ce7-4cdd-b7b4-8899ea88d289" providerId="ADAL" clId="{ADEEF08A-D719-4B50-A383-4105EDA2C206}" dt="2026-03-06T13:06:36.870" v="1828" actId="14100"/>
           <ac:picMkLst>
@@ -979,7 +915,7 @@
         </pc:spChg>
       </pc:sldChg>
       <pc:sldChg chg="modSp mod ord">
-        <pc:chgData name="Graf Thomas, SCS-INI-NET-VNC-E2E" userId="487bc3e3-9ce7-4cdd-b7b4-8899ea88d289" providerId="ADAL" clId="{ADEEF08A-D719-4B50-A383-4105EDA2C206}" dt="2026-03-06T15:07:43.748" v="5907" actId="20577"/>
+        <pc:chgData name="Graf Thomas, SCS-INI-NET-VNC-E2E" userId="487bc3e3-9ce7-4cdd-b7b4-8899ea88d289" providerId="ADAL" clId="{ADEEF08A-D719-4B50-A383-4105EDA2C206}" dt="2026-03-09T09:47:38.204" v="6109"/>
         <pc:sldMkLst>
           <pc:docMk/>
           <pc:sldMk cId="4251917088" sldId="2145706303"/>
@@ -1040,13 +976,13 @@
         </pc:spChg>
       </pc:sldChg>
       <pc:sldChg chg="delSp modSp mod">
-        <pc:chgData name="Graf Thomas, SCS-INI-NET-VNC-E2E" userId="487bc3e3-9ce7-4cdd-b7b4-8899ea88d289" providerId="ADAL" clId="{ADEEF08A-D719-4B50-A383-4105EDA2C206}" dt="2026-03-06T15:01:38.879" v="5753" actId="14100"/>
+        <pc:chgData name="Graf Thomas, SCS-INI-NET-VNC-E2E" userId="487bc3e3-9ce7-4cdd-b7b4-8899ea88d289" providerId="ADAL" clId="{ADEEF08A-D719-4B50-A383-4105EDA2C206}" dt="2026-03-09T09:48:28.303" v="6111" actId="790"/>
         <pc:sldMkLst>
           <pc:docMk/>
           <pc:sldMk cId="3305081943" sldId="2145706306"/>
         </pc:sldMkLst>
         <pc:spChg chg="mod">
-          <ac:chgData name="Graf Thomas, SCS-INI-NET-VNC-E2E" userId="487bc3e3-9ce7-4cdd-b7b4-8899ea88d289" providerId="ADAL" clId="{ADEEF08A-D719-4B50-A383-4105EDA2C206}" dt="2026-03-06T14:59:06.358" v="5667" actId="20577"/>
+          <ac:chgData name="Graf Thomas, SCS-INI-NET-VNC-E2E" userId="487bc3e3-9ce7-4cdd-b7b4-8899ea88d289" providerId="ADAL" clId="{ADEEF08A-D719-4B50-A383-4105EDA2C206}" dt="2026-03-09T09:48:28.303" v="6111" actId="790"/>
           <ac:spMkLst>
             <pc:docMk/>
             <pc:sldMk cId="3305081943" sldId="2145706306"/>
@@ -1054,24 +990,24 @@
           </ac:spMkLst>
         </pc:spChg>
         <pc:spChg chg="mod">
-          <ac:chgData name="Graf Thomas, SCS-INI-NET-VNC-E2E" userId="487bc3e3-9ce7-4cdd-b7b4-8899ea88d289" providerId="ADAL" clId="{ADEEF08A-D719-4B50-A383-4105EDA2C206}" dt="2026-03-06T15:01:38.879" v="5753" actId="14100"/>
+          <ac:chgData name="Graf Thomas, SCS-INI-NET-VNC-E2E" userId="487bc3e3-9ce7-4cdd-b7b4-8899ea88d289" providerId="ADAL" clId="{ADEEF08A-D719-4B50-A383-4105EDA2C206}" dt="2026-03-09T09:48:28.303" v="6111" actId="790"/>
           <ac:spMkLst>
             <pc:docMk/>
             <pc:sldMk cId="3305081943" sldId="2145706306"/>
             <ac:spMk id="3" creationId="{3EA36F6F-A76C-ACD7-BA9E-6565DCCE91FE}"/>
           </ac:spMkLst>
         </pc:spChg>
-        <pc:spChg chg="del">
-          <ac:chgData name="Graf Thomas, SCS-INI-NET-VNC-E2E" userId="487bc3e3-9ce7-4cdd-b7b4-8899ea88d289" providerId="ADAL" clId="{ADEEF08A-D719-4B50-A383-4105EDA2C206}" dt="2026-03-06T14:25:32.316" v="4331" actId="478"/>
+        <pc:spChg chg="mod">
+          <ac:chgData name="Graf Thomas, SCS-INI-NET-VNC-E2E" userId="487bc3e3-9ce7-4cdd-b7b4-8899ea88d289" providerId="ADAL" clId="{ADEEF08A-D719-4B50-A383-4105EDA2C206}" dt="2026-03-09T09:48:28.303" v="6111" actId="790"/>
           <ac:spMkLst>
             <pc:docMk/>
             <pc:sldMk cId="3305081943" sldId="2145706306"/>
-            <ac:spMk id="4" creationId="{59CFE947-4A29-3EDA-9CF4-2F6E346A50BB}"/>
+            <ac:spMk id="6" creationId="{B9866352-2EDF-D4FC-27E7-72035010FE1B}"/>
           </ac:spMkLst>
         </pc:spChg>
       </pc:sldChg>
       <pc:sldChg chg="addSp delSp modSp add mod">
-        <pc:chgData name="Graf Thomas, SCS-INI-NET-VNC-E2E" userId="487bc3e3-9ce7-4cdd-b7b4-8899ea88d289" providerId="ADAL" clId="{ADEEF08A-D719-4B50-A383-4105EDA2C206}" dt="2026-03-01T13:13:40.095" v="544" actId="1076"/>
+        <pc:chgData name="Graf Thomas, SCS-INI-NET-VNC-E2E" userId="487bc3e3-9ce7-4cdd-b7b4-8899ea88d289" providerId="ADAL" clId="{ADEEF08A-D719-4B50-A383-4105EDA2C206}" dt="2026-03-07T09:33:00.256" v="6107" actId="1076"/>
         <pc:sldMkLst>
           <pc:docMk/>
           <pc:sldMk cId="2590364080" sldId="2145706307"/>
@@ -1085,7 +1021,7 @@
           </ac:spMkLst>
         </pc:spChg>
         <pc:spChg chg="mod">
-          <ac:chgData name="Graf Thomas, SCS-INI-NET-VNC-E2E" userId="487bc3e3-9ce7-4cdd-b7b4-8899ea88d289" providerId="ADAL" clId="{ADEEF08A-D719-4B50-A383-4105EDA2C206}" dt="2026-03-01T13:13:34.864" v="542" actId="108"/>
+          <ac:chgData name="Graf Thomas, SCS-INI-NET-VNC-E2E" userId="487bc3e3-9ce7-4cdd-b7b4-8899ea88d289" providerId="ADAL" clId="{ADEEF08A-D719-4B50-A383-4105EDA2C206}" dt="2026-03-07T09:33:00.256" v="6107" actId="1076"/>
           <ac:spMkLst>
             <pc:docMk/>
             <pc:sldMk cId="2590364080" sldId="2145706307"/>
@@ -1226,22 +1162,6 @@
             <ac:spMk id="3" creationId="{3F4CBE7F-1450-A754-E524-9EE662BEDE60}"/>
           </ac:spMkLst>
         </pc:spChg>
-        <pc:spChg chg="del">
-          <ac:chgData name="Graf Thomas, SCS-INI-NET-VNC-E2E" userId="487bc3e3-9ce7-4cdd-b7b4-8899ea88d289" providerId="ADAL" clId="{ADEEF08A-D719-4B50-A383-4105EDA2C206}" dt="2026-03-06T14:39:59.598" v="4953" actId="478"/>
-          <ac:spMkLst>
-            <pc:docMk/>
-            <pc:sldMk cId="2961389282" sldId="2145706309"/>
-            <ac:spMk id="4" creationId="{80214517-94D3-3E3D-2E98-06A46DCC5C7F}"/>
-          </ac:spMkLst>
-        </pc:spChg>
-        <pc:spChg chg="add del mod">
-          <ac:chgData name="Graf Thomas, SCS-INI-NET-VNC-E2E" userId="487bc3e3-9ce7-4cdd-b7b4-8899ea88d289" providerId="ADAL" clId="{ADEEF08A-D719-4B50-A383-4105EDA2C206}" dt="2026-03-06T14:55:41.656" v="5564" actId="478"/>
-          <ac:spMkLst>
-            <pc:docMk/>
-            <pc:sldMk cId="2961389282" sldId="2145706309"/>
-            <ac:spMk id="5" creationId="{BAC700CD-232F-EB1B-9D91-D39FEE63C255}"/>
-          </ac:spMkLst>
-        </pc:spChg>
       </pc:sldChg>
       <pc:sldChg chg="modSp add mod">
         <pc:chgData name="Graf Thomas, SCS-INI-NET-VNC-E2E" userId="487bc3e3-9ce7-4cdd-b7b4-8899ea88d289" providerId="ADAL" clId="{ADEEF08A-D719-4B50-A383-4105EDA2C206}" dt="2026-03-06T15:02:28.468" v="5769" actId="20577"/>
@@ -1331,22 +1251,6 @@
           <pc:docMk/>
           <pc:sldMk cId="3812470375" sldId="2145706316"/>
         </pc:sldMkLst>
-        <pc:spChg chg="mod">
-          <ac:chgData name="Graf Thomas, SCS-INI-NET-VNC-E2E" userId="487bc3e3-9ce7-4cdd-b7b4-8899ea88d289" providerId="ADAL" clId="{ADEEF08A-D719-4B50-A383-4105EDA2C206}" dt="2026-03-06T15:21:27.552" v="6042" actId="207"/>
-          <ac:spMkLst>
-            <pc:docMk/>
-            <pc:sldMk cId="3812470375" sldId="2145706316"/>
-            <ac:spMk id="2" creationId="{FF20F271-6F0D-4AC0-BB1D-F5C338165C13}"/>
-          </ac:spMkLst>
-        </pc:spChg>
-        <pc:spChg chg="mod">
-          <ac:chgData name="Graf Thomas, SCS-INI-NET-VNC-E2E" userId="487bc3e3-9ce7-4cdd-b7b4-8899ea88d289" providerId="ADAL" clId="{ADEEF08A-D719-4B50-A383-4105EDA2C206}" dt="2026-03-06T15:22:04.836" v="6079" actId="207"/>
-          <ac:spMkLst>
-            <pc:docMk/>
-            <pc:sldMk cId="3812470375" sldId="2145706316"/>
-            <ac:spMk id="3" creationId="{29C0DFD4-432D-4B0C-93DF-790441DCF5B9}"/>
-          </ac:spMkLst>
-        </pc:spChg>
       </pc:sldChg>
     </pc:docChg>
   </pc:docChgLst>
@@ -1435,7 +1339,7 @@
           <a:p>
             <a:fld id="{E5E705E9-673F-4AC4-B29E-A7B26F3B8523}" type="datetimeFigureOut">
               <a:rPr lang="de-CH" smtClean="0"/>
-              <a:t>06.03.2026</a:t>
+              <a:t>09.03.2026</a:t>
             </a:fld>
             <a:endParaRPr lang="de-CH"/>
           </a:p>
@@ -2109,7 +2013,7 @@
           <a:p>
             <a:fld id="{9E9B238C-2335-4007-98C9-471C02CC43B6}" type="datetimeFigureOut">
               <a:rPr lang="de-CH" smtClean="0"/>
-              <a:t>06.03.2026</a:t>
+              <a:t>09.03.2026</a:t>
             </a:fld>
             <a:endParaRPr lang="de-CH"/>
           </a:p>
@@ -2309,7 +2213,7 @@
           <a:p>
             <a:fld id="{9E9B238C-2335-4007-98C9-471C02CC43B6}" type="datetimeFigureOut">
               <a:rPr lang="de-CH" smtClean="0"/>
-              <a:t>06.03.2026</a:t>
+              <a:t>09.03.2026</a:t>
             </a:fld>
             <a:endParaRPr lang="de-CH"/>
           </a:p>
@@ -2519,7 +2423,7 @@
           <a:p>
             <a:fld id="{9E9B238C-2335-4007-98C9-471C02CC43B6}" type="datetimeFigureOut">
               <a:rPr lang="de-CH" smtClean="0"/>
-              <a:t>06.03.2026</a:t>
+              <a:t>09.03.2026</a:t>
             </a:fld>
             <a:endParaRPr lang="de-CH"/>
           </a:p>
@@ -3961,7 +3865,7 @@
           <a:p>
             <a:fld id="{9E9B238C-2335-4007-98C9-471C02CC43B6}" type="datetimeFigureOut">
               <a:rPr lang="de-CH" smtClean="0"/>
-              <a:t>06.03.2026</a:t>
+              <a:t>09.03.2026</a:t>
             </a:fld>
             <a:endParaRPr lang="de-CH"/>
           </a:p>
@@ -4237,7 +4141,7 @@
           <a:p>
             <a:fld id="{9E9B238C-2335-4007-98C9-471C02CC43B6}" type="datetimeFigureOut">
               <a:rPr lang="de-CH" smtClean="0"/>
-              <a:t>06.03.2026</a:t>
+              <a:t>09.03.2026</a:t>
             </a:fld>
             <a:endParaRPr lang="de-CH"/>
           </a:p>
@@ -4505,7 +4409,7 @@
           <a:p>
             <a:fld id="{9E9B238C-2335-4007-98C9-471C02CC43B6}" type="datetimeFigureOut">
               <a:rPr lang="de-CH" smtClean="0"/>
-              <a:t>06.03.2026</a:t>
+              <a:t>09.03.2026</a:t>
             </a:fld>
             <a:endParaRPr lang="de-CH"/>
           </a:p>
@@ -4920,7 +4824,7 @@
           <a:p>
             <a:fld id="{9E9B238C-2335-4007-98C9-471C02CC43B6}" type="datetimeFigureOut">
               <a:rPr lang="de-CH" smtClean="0"/>
-              <a:t>06.03.2026</a:t>
+              <a:t>09.03.2026</a:t>
             </a:fld>
             <a:endParaRPr lang="de-CH"/>
           </a:p>
@@ -5062,7 +4966,7 @@
           <a:p>
             <a:fld id="{9E9B238C-2335-4007-98C9-471C02CC43B6}" type="datetimeFigureOut">
               <a:rPr lang="de-CH" smtClean="0"/>
-              <a:t>06.03.2026</a:t>
+              <a:t>09.03.2026</a:t>
             </a:fld>
             <a:endParaRPr lang="de-CH"/>
           </a:p>
@@ -5175,7 +5079,7 @@
           <a:p>
             <a:fld id="{9E9B238C-2335-4007-98C9-471C02CC43B6}" type="datetimeFigureOut">
               <a:rPr lang="de-CH" smtClean="0"/>
-              <a:t>06.03.2026</a:t>
+              <a:t>09.03.2026</a:t>
             </a:fld>
             <a:endParaRPr lang="de-CH"/>
           </a:p>
@@ -5488,7 +5392,7 @@
           <a:p>
             <a:fld id="{9E9B238C-2335-4007-98C9-471C02CC43B6}" type="datetimeFigureOut">
               <a:rPr lang="de-CH" smtClean="0"/>
-              <a:t>06.03.2026</a:t>
+              <a:t>09.03.2026</a:t>
             </a:fld>
             <a:endParaRPr lang="de-CH"/>
           </a:p>
@@ -5777,7 +5681,7 @@
           <a:p>
             <a:fld id="{9E9B238C-2335-4007-98C9-471C02CC43B6}" type="datetimeFigureOut">
               <a:rPr lang="de-CH" smtClean="0"/>
-              <a:t>06.03.2026</a:t>
+              <a:t>09.03.2026</a:t>
             </a:fld>
             <a:endParaRPr lang="de-CH"/>
           </a:p>
@@ -6020,7 +5924,7 @@
           <a:p>
             <a:fld id="{9E9B238C-2335-4007-98C9-471C02CC43B6}" type="datetimeFigureOut">
               <a:rPr lang="de-CH" smtClean="0"/>
-              <a:t>06.03.2026</a:t>
+              <a:t>09.03.2026</a:t>
             </a:fld>
             <a:endParaRPr lang="de-CH"/>
           </a:p>
@@ -6865,7 +6769,7 @@
               <a:rPr lang="en-US" sz="1400" dirty="0">
                 <a:latin typeface="+mj-lt"/>
               </a:rPr>
-              <a:t>06. March </a:t>
+              <a:t>09. March </a:t>
             </a:r>
             <a:r>
               <a:rPr lang="en-US" sz="1400" dirty="0">
@@ -7380,6 +7284,262 @@
         <p:cNvPr id="1" name="">
           <a:extLst>
             <a:ext uri="{FF2B5EF4-FFF2-40B4-BE49-F238E27FC236}">
+              <a16:creationId xmlns:a16="http://schemas.microsoft.com/office/drawing/2014/main" id="{AAC0F139-79A7-236E-B422-F9027B252B94}"/>
+            </a:ext>
+          </a:extLst>
+        </p:cNvPr>
+        <p:cNvGrpSpPr/>
+        <p:nvPr/>
+      </p:nvGrpSpPr>
+      <p:grpSpPr>
+        <a:xfrm>
+          <a:off x="0" y="0"/>
+          <a:ext cx="0" cy="0"/>
+          <a:chOff x="0" y="0"/>
+          <a:chExt cx="0" cy="0"/>
+        </a:xfrm>
+      </p:grpSpPr>
+      <p:sp>
+        <p:nvSpPr>
+          <p:cNvPr id="2" name="Title 1">
+            <a:extLst>
+              <a:ext uri="{FF2B5EF4-FFF2-40B4-BE49-F238E27FC236}">
+                <a16:creationId xmlns:a16="http://schemas.microsoft.com/office/drawing/2014/main" id="{9D734BEF-C196-3BAF-0F2E-FB66BF042884}"/>
+              </a:ext>
+            </a:extLst>
+          </p:cNvPr>
+          <p:cNvSpPr>
+            <a:spLocks noGrp="1"/>
+          </p:cNvSpPr>
+          <p:nvPr>
+            <p:ph type="title"/>
+          </p:nvPr>
+        </p:nvSpPr>
+        <p:spPr/>
+        <p:txBody>
+          <a:bodyPr>
+            <a:normAutofit/>
+          </a:bodyPr>
+          <a:lstStyle/>
+          <a:p>
+            <a:r>
+              <a:rPr lang="en-US" sz="2800" b="1" dirty="0"/>
+              <a:t>BMP YANG Message Broker Topic Naming</a:t>
+            </a:r>
+            <a:br>
+              <a:rPr lang="en-US" sz="3600" dirty="0"/>
+            </a:br>
+            <a:r>
+              <a:rPr lang="en-US" sz="2700" dirty="0">
+                <a:solidFill>
+                  <a:schemeClr val="bg2">
+                    <a:lumMod val="75000"/>
+                  </a:schemeClr>
+                </a:solidFill>
+              </a:rPr>
+              <a:t>Created at the YANG Message Broker Producer</a:t>
+            </a:r>
+          </a:p>
+        </p:txBody>
+      </p:sp>
+      <p:sp>
+        <p:nvSpPr>
+          <p:cNvPr id="3" name="Content Placeholder 2">
+            <a:extLst>
+              <a:ext uri="{FF2B5EF4-FFF2-40B4-BE49-F238E27FC236}">
+                <a16:creationId xmlns:a16="http://schemas.microsoft.com/office/drawing/2014/main" id="{6EA985DA-ABCF-AB10-5C45-1B7050950E17}"/>
+              </a:ext>
+            </a:extLst>
+          </p:cNvPr>
+          <p:cNvSpPr>
+            <a:spLocks noGrp="1"/>
+          </p:cNvSpPr>
+          <p:nvPr>
+            <p:ph idx="1"/>
+          </p:nvPr>
+        </p:nvSpPr>
+        <p:spPr>
+          <a:xfrm>
+            <a:off x="838199" y="1690688"/>
+            <a:ext cx="10515600" cy="4486275"/>
+          </a:xfrm>
+        </p:spPr>
+        <p:txBody>
+          <a:bodyPr>
+            <a:noAutofit/>
+          </a:bodyPr>
+          <a:lstStyle/>
+          <a:p>
+            <a:pPr marL="0" indent="0">
+              <a:spcBef>
+                <a:spcPts val="600"/>
+              </a:spcBef>
+              <a:spcAft>
+                <a:spcPts val="600"/>
+              </a:spcAft>
+              <a:buNone/>
+            </a:pPr>
+            <a:r>
+              <a:rPr lang="en-US" sz="2100" dirty="0"/>
+              <a:t>BMP data can be subscribed for BMP session and BGP peering session state-changes, BGP peering statistics or BGP RIB states. as defined in </a:t>
+            </a:r>
+            <a:r>
+              <a:rPr lang="en-US" sz="2100" dirty="0">
+                <a:hlinkClick r:id="rId2"/>
+              </a:rPr>
+              <a:t>Section 3.1 of RFC 7854</a:t>
+            </a:r>
+            <a:r>
+              <a:rPr lang="en-US" sz="2100" dirty="0"/>
+              <a:t>.</a:t>
+            </a:r>
+          </a:p>
+          <a:p>
+            <a:pPr marL="0" indent="0">
+              <a:spcBef>
+                <a:spcPts val="600"/>
+              </a:spcBef>
+              <a:spcAft>
+                <a:spcPts val="600"/>
+              </a:spcAft>
+              <a:buNone/>
+            </a:pPr>
+            <a:r>
+              <a:rPr lang="en-US" sz="2100" dirty="0"/>
+              <a:t>Message Brokers topics are addressed with a unique name.  Usually, topics are named hierarchically similar to the DNS namespace where "." delaminates hierarchies.</a:t>
+            </a:r>
+          </a:p>
+          <a:p>
+            <a:pPr marL="0" indent="0">
+              <a:spcBef>
+                <a:spcPts val="600"/>
+              </a:spcBef>
+              <a:spcAft>
+                <a:spcPts val="600"/>
+              </a:spcAft>
+              <a:buNone/>
+            </a:pPr>
+            <a:r>
+              <a:rPr lang="en-US" sz="2100" dirty="0"/>
+              <a:t>The document defines "statistics", "states" and "state-changes" in the topic name as the first part to denote the types of data. Followed by "bmp" to denote BMP data.  Followed by the BGP RIB type and the BMP message type name.</a:t>
+            </a:r>
+          </a:p>
+          <a:p>
+            <a:pPr marL="0" indent="0">
+              <a:spcBef>
+                <a:spcPts val="600"/>
+              </a:spcBef>
+              <a:spcAft>
+                <a:spcPts val="600"/>
+              </a:spcAft>
+              <a:buNone/>
+            </a:pPr>
+            <a:r>
+              <a:rPr lang="en-US" sz="2100" dirty="0"/>
+              <a:t>For example, if BMP route-monitoring is being subscribed to BGP Local-RIB, the Message Broker topic name would be as following. In the example the project name and environment (prod, dev, test etc.) is prefixed. </a:t>
+            </a:r>
+          </a:p>
+          <a:p>
+            <a:pPr marL="0" indent="0">
+              <a:spcBef>
+                <a:spcPts val="600"/>
+              </a:spcBef>
+              <a:spcAft>
+                <a:spcPts val="600"/>
+              </a:spcAft>
+              <a:buNone/>
+            </a:pPr>
+            <a:r>
+              <a:rPr lang="en-US" sz="2100" b="1" dirty="0" err="1">
+                <a:solidFill>
+                  <a:srgbClr val="FF0000"/>
+                </a:solidFill>
+              </a:rPr>
+              <a:t>project.environment.state.bmp.local</a:t>
+            </a:r>
+            <a:r>
+              <a:rPr lang="en-US" sz="2100" b="1" dirty="0">
+                <a:solidFill>
+                  <a:srgbClr val="FF0000"/>
+                </a:solidFill>
+              </a:rPr>
+              <a:t>-</a:t>
+            </a:r>
+            <a:r>
+              <a:rPr lang="en-US" sz="2100" b="1" dirty="0" err="1">
+                <a:solidFill>
+                  <a:srgbClr val="FF0000"/>
+                </a:solidFill>
+              </a:rPr>
+              <a:t>rib.route</a:t>
+            </a:r>
+            <a:r>
+              <a:rPr lang="en-US" sz="2100" b="1" dirty="0">
+                <a:solidFill>
+                  <a:srgbClr val="FF0000"/>
+                </a:solidFill>
+              </a:rPr>
+              <a:t>-monitoring</a:t>
+            </a:r>
+            <a:endParaRPr lang="en-US" sz="2100" dirty="0"/>
+          </a:p>
+        </p:txBody>
+      </p:sp>
+      <p:sp>
+        <p:nvSpPr>
+          <p:cNvPr id="6" name="Slide Number Placeholder 1">
+            <a:extLst>
+              <a:ext uri="{FF2B5EF4-FFF2-40B4-BE49-F238E27FC236}">
+                <a16:creationId xmlns:a16="http://schemas.microsoft.com/office/drawing/2014/main" id="{6FA6137A-D97E-E8DA-4B6E-B20E079C61E4}"/>
+              </a:ext>
+            </a:extLst>
+          </p:cNvPr>
+          <p:cNvSpPr>
+            <a:spLocks noGrp="1"/>
+          </p:cNvSpPr>
+          <p:nvPr>
+            <p:ph type="sldNum" sz="quarter" idx="12"/>
+          </p:nvPr>
+        </p:nvSpPr>
+        <p:spPr>
+          <a:xfrm>
+            <a:off x="11587892" y="6361637"/>
+            <a:ext cx="414251" cy="365125"/>
+          </a:xfrm>
+        </p:spPr>
+        <p:txBody>
+          <a:bodyPr/>
+          <a:lstStyle/>
+          <a:p>
+            <a:fld id="{FC4AC485-25DE-431E-B345-9C0A15BB7F8A}" type="slidenum">
+              <a:rPr lang="en-US" sz="1400" smtClean="0"/>
+              <a:t>11</a:t>
+            </a:fld>
+            <a:endParaRPr lang="en-US" sz="1400" dirty="0"/>
+          </a:p>
+        </p:txBody>
+      </p:sp>
+    </p:spTree>
+    <p:extLst>
+      <p:ext uri="{BB962C8B-B14F-4D97-AF65-F5344CB8AC3E}">
+        <p14:creationId xmlns:p14="http://schemas.microsoft.com/office/powerpoint/2010/main" val="4251917088"/>
+      </p:ext>
+    </p:extLst>
+  </p:cSld>
+  <p:clrMapOvr>
+    <a:masterClrMapping/>
+  </p:clrMapOvr>
+</p:sld>
+</file>
+
+<file path=ppt/slides/slide12.xml><?xml version="1.0" encoding="utf-8"?>
+<p:sld xmlns:a="http://schemas.openxmlformats.org/drawingml/2006/main" xmlns:r="http://schemas.openxmlformats.org/officeDocument/2006/relationships" xmlns:p="http://schemas.openxmlformats.org/presentationml/2006/main">
+  <p:cSld>
+    <p:spTree>
+      <p:nvGrpSpPr>
+        <p:cNvPr id="1" name="">
+          <a:extLst>
+            <a:ext uri="{FF2B5EF4-FFF2-40B4-BE49-F238E27FC236}">
               <a16:creationId xmlns:a16="http://schemas.microsoft.com/office/drawing/2014/main" id="{9952B289-F416-C973-3B7A-15C1F41DA5AB}"/>
             </a:ext>
           </a:extLst>
@@ -7644,7 +7804,7 @@
           <a:p>
             <a:fld id="{FC4AC485-25DE-431E-B345-9C0A15BB7F8A}" type="slidenum">
               <a:rPr lang="en-US" sz="1400" smtClean="0"/>
-              <a:t>11</a:t>
+              <a:t>12</a:t>
             </a:fld>
             <a:endParaRPr lang="en-US" sz="1400" dirty="0"/>
           </a:p>
@@ -7654,262 +7814,6 @@
     <p:extLst>
       <p:ext uri="{BB962C8B-B14F-4D97-AF65-F5344CB8AC3E}">
         <p14:creationId xmlns:p14="http://schemas.microsoft.com/office/powerpoint/2010/main" val="1190312228"/>
-      </p:ext>
-    </p:extLst>
-  </p:cSld>
-  <p:clrMapOvr>
-    <a:masterClrMapping/>
-  </p:clrMapOvr>
-</p:sld>
-</file>
-
-<file path=ppt/slides/slide12.xml><?xml version="1.0" encoding="utf-8"?>
-<p:sld xmlns:a="http://schemas.openxmlformats.org/drawingml/2006/main" xmlns:r="http://schemas.openxmlformats.org/officeDocument/2006/relationships" xmlns:p="http://schemas.openxmlformats.org/presentationml/2006/main">
-  <p:cSld>
-    <p:spTree>
-      <p:nvGrpSpPr>
-        <p:cNvPr id="1" name="">
-          <a:extLst>
-            <a:ext uri="{FF2B5EF4-FFF2-40B4-BE49-F238E27FC236}">
-              <a16:creationId xmlns:a16="http://schemas.microsoft.com/office/drawing/2014/main" id="{AAC0F139-79A7-236E-B422-F9027B252B94}"/>
-            </a:ext>
-          </a:extLst>
-        </p:cNvPr>
-        <p:cNvGrpSpPr/>
-        <p:nvPr/>
-      </p:nvGrpSpPr>
-      <p:grpSpPr>
-        <a:xfrm>
-          <a:off x="0" y="0"/>
-          <a:ext cx="0" cy="0"/>
-          <a:chOff x="0" y="0"/>
-          <a:chExt cx="0" cy="0"/>
-        </a:xfrm>
-      </p:grpSpPr>
-      <p:sp>
-        <p:nvSpPr>
-          <p:cNvPr id="2" name="Title 1">
-            <a:extLst>
-              <a:ext uri="{FF2B5EF4-FFF2-40B4-BE49-F238E27FC236}">
-                <a16:creationId xmlns:a16="http://schemas.microsoft.com/office/drawing/2014/main" id="{9D734BEF-C196-3BAF-0F2E-FB66BF042884}"/>
-              </a:ext>
-            </a:extLst>
-          </p:cNvPr>
-          <p:cNvSpPr>
-            <a:spLocks noGrp="1"/>
-          </p:cNvSpPr>
-          <p:nvPr>
-            <p:ph type="title"/>
-          </p:nvPr>
-        </p:nvSpPr>
-        <p:spPr/>
-        <p:txBody>
-          <a:bodyPr>
-            <a:normAutofit/>
-          </a:bodyPr>
-          <a:lstStyle/>
-          <a:p>
-            <a:r>
-              <a:rPr lang="en-US" sz="2800" b="1" dirty="0"/>
-              <a:t>BMP YANG Message Broker Topic Naming</a:t>
-            </a:r>
-            <a:br>
-              <a:rPr lang="en-US" sz="3600" dirty="0"/>
-            </a:br>
-            <a:r>
-              <a:rPr lang="en-US" sz="2700" dirty="0">
-                <a:solidFill>
-                  <a:schemeClr val="bg2">
-                    <a:lumMod val="75000"/>
-                  </a:schemeClr>
-                </a:solidFill>
-              </a:rPr>
-              <a:t>Created at the YANG Message Broker Producer</a:t>
-            </a:r>
-          </a:p>
-        </p:txBody>
-      </p:sp>
-      <p:sp>
-        <p:nvSpPr>
-          <p:cNvPr id="3" name="Content Placeholder 2">
-            <a:extLst>
-              <a:ext uri="{FF2B5EF4-FFF2-40B4-BE49-F238E27FC236}">
-                <a16:creationId xmlns:a16="http://schemas.microsoft.com/office/drawing/2014/main" id="{6EA985DA-ABCF-AB10-5C45-1B7050950E17}"/>
-              </a:ext>
-            </a:extLst>
-          </p:cNvPr>
-          <p:cNvSpPr>
-            <a:spLocks noGrp="1"/>
-          </p:cNvSpPr>
-          <p:nvPr>
-            <p:ph idx="1"/>
-          </p:nvPr>
-        </p:nvSpPr>
-        <p:spPr>
-          <a:xfrm>
-            <a:off x="838199" y="1690688"/>
-            <a:ext cx="10515600" cy="4486275"/>
-          </a:xfrm>
-        </p:spPr>
-        <p:txBody>
-          <a:bodyPr>
-            <a:noAutofit/>
-          </a:bodyPr>
-          <a:lstStyle/>
-          <a:p>
-            <a:pPr marL="0" indent="0">
-              <a:spcBef>
-                <a:spcPts val="600"/>
-              </a:spcBef>
-              <a:spcAft>
-                <a:spcPts val="600"/>
-              </a:spcAft>
-              <a:buNone/>
-            </a:pPr>
-            <a:r>
-              <a:rPr lang="en-US" sz="2100" dirty="0"/>
-              <a:t>BMP data can be subscribed for BMP session and BGP peering session state-changes, BGP peering statistics or BGP RIB states. as defined in </a:t>
-            </a:r>
-            <a:r>
-              <a:rPr lang="en-US" sz="2100" dirty="0">
-                <a:hlinkClick r:id="rId2"/>
-              </a:rPr>
-              <a:t>Section 3.1 of RFC 7854</a:t>
-            </a:r>
-            <a:r>
-              <a:rPr lang="en-US" sz="2100" dirty="0"/>
-              <a:t>.</a:t>
-            </a:r>
-          </a:p>
-          <a:p>
-            <a:pPr marL="0" indent="0">
-              <a:spcBef>
-                <a:spcPts val="600"/>
-              </a:spcBef>
-              <a:spcAft>
-                <a:spcPts val="600"/>
-              </a:spcAft>
-              <a:buNone/>
-            </a:pPr>
-            <a:r>
-              <a:rPr lang="en-US" sz="2100" dirty="0"/>
-              <a:t>Message Brokers topics are addressed with a unique name.  Usually, topics are named hierarchically similar to the DNS namespace where "." delaminates hierarchies.</a:t>
-            </a:r>
-          </a:p>
-          <a:p>
-            <a:pPr marL="0" indent="0">
-              <a:spcBef>
-                <a:spcPts val="600"/>
-              </a:spcBef>
-              <a:spcAft>
-                <a:spcPts val="600"/>
-              </a:spcAft>
-              <a:buNone/>
-            </a:pPr>
-            <a:r>
-              <a:rPr lang="en-US" sz="2100" dirty="0"/>
-              <a:t>The document defines "statistics", "states" and "state-changes" in the topic name as the first part to denote the types of data. Followed by "bmp" to denote BMP data.  Followed by the BGP RIB type and the BMP message type name.</a:t>
-            </a:r>
-          </a:p>
-          <a:p>
-            <a:pPr marL="0" indent="0">
-              <a:spcBef>
-                <a:spcPts val="600"/>
-              </a:spcBef>
-              <a:spcAft>
-                <a:spcPts val="600"/>
-              </a:spcAft>
-              <a:buNone/>
-            </a:pPr>
-            <a:r>
-              <a:rPr lang="en-US" sz="2100" dirty="0"/>
-              <a:t>For example, if BMP route-monitoring is being subscribed to BGP Local-RIB, the Message Broker topic name would be as following. In the example the project name and environment (prod, dev, test etc.) is prefixed. </a:t>
-            </a:r>
-          </a:p>
-          <a:p>
-            <a:pPr marL="0" indent="0">
-              <a:spcBef>
-                <a:spcPts val="600"/>
-              </a:spcBef>
-              <a:spcAft>
-                <a:spcPts val="600"/>
-              </a:spcAft>
-              <a:buNone/>
-            </a:pPr>
-            <a:r>
-              <a:rPr lang="en-US" sz="2100" b="1" dirty="0" err="1">
-                <a:solidFill>
-                  <a:srgbClr val="FF0000"/>
-                </a:solidFill>
-              </a:rPr>
-              <a:t>project.environment.state.bmp.local</a:t>
-            </a:r>
-            <a:r>
-              <a:rPr lang="en-US" sz="2100" b="1" dirty="0">
-                <a:solidFill>
-                  <a:srgbClr val="FF0000"/>
-                </a:solidFill>
-              </a:rPr>
-              <a:t>-</a:t>
-            </a:r>
-            <a:r>
-              <a:rPr lang="en-US" sz="2100" b="1" dirty="0" err="1">
-                <a:solidFill>
-                  <a:srgbClr val="FF0000"/>
-                </a:solidFill>
-              </a:rPr>
-              <a:t>rib.route</a:t>
-            </a:r>
-            <a:r>
-              <a:rPr lang="en-US" sz="2100" b="1" dirty="0">
-                <a:solidFill>
-                  <a:srgbClr val="FF0000"/>
-                </a:solidFill>
-              </a:rPr>
-              <a:t>-monitoring</a:t>
-            </a:r>
-            <a:endParaRPr lang="en-US" sz="2100" dirty="0"/>
-          </a:p>
-        </p:txBody>
-      </p:sp>
-      <p:sp>
-        <p:nvSpPr>
-          <p:cNvPr id="6" name="Slide Number Placeholder 1">
-            <a:extLst>
-              <a:ext uri="{FF2B5EF4-FFF2-40B4-BE49-F238E27FC236}">
-                <a16:creationId xmlns:a16="http://schemas.microsoft.com/office/drawing/2014/main" id="{6FA6137A-D97E-E8DA-4B6E-B20E079C61E4}"/>
-              </a:ext>
-            </a:extLst>
-          </p:cNvPr>
-          <p:cNvSpPr>
-            <a:spLocks noGrp="1"/>
-          </p:cNvSpPr>
-          <p:nvPr>
-            <p:ph type="sldNum" sz="quarter" idx="12"/>
-          </p:nvPr>
-        </p:nvSpPr>
-        <p:spPr>
-          <a:xfrm>
-            <a:off x="11587892" y="6361637"/>
-            <a:ext cx="414251" cy="365125"/>
-          </a:xfrm>
-        </p:spPr>
-        <p:txBody>
-          <a:bodyPr/>
-          <a:lstStyle/>
-          <a:p>
-            <a:fld id="{FC4AC485-25DE-431E-B345-9C0A15BB7F8A}" type="slidenum">
-              <a:rPr lang="en-US" sz="1400" smtClean="0"/>
-              <a:t>12</a:t>
-            </a:fld>
-            <a:endParaRPr lang="en-US" sz="1400" dirty="0"/>
-          </a:p>
-        </p:txBody>
-      </p:sp>
-    </p:spTree>
-    <p:extLst>
-      <p:ext uri="{BB962C8B-B14F-4D97-AF65-F5344CB8AC3E}">
-        <p14:creationId xmlns:p14="http://schemas.microsoft.com/office/powerpoint/2010/main" val="4251917088"/>
       </p:ext>
     </p:extLst>
   </p:cSld>
@@ -9371,14 +9275,14 @@
           <a:lstStyle/>
           <a:p>
             <a:r>
-              <a:rPr lang="en-US" sz="2800" b="1" dirty="0"/>
+              <a:rPr lang="en-US" sz="2800" b="1" noProof="0" dirty="0"/>
               <a:t>Questions to…</a:t>
             </a:r>
             <a:br>
-              <a:rPr lang="en-US" sz="3600" dirty="0"/>
+              <a:rPr lang="en-US" sz="3600" noProof="0" dirty="0"/>
             </a:br>
             <a:r>
-              <a:rPr lang="en-US" sz="2700" dirty="0">
+              <a:rPr lang="en-US" sz="2700" noProof="0" dirty="0">
                 <a:solidFill>
                   <a:schemeClr val="bg2">
                     <a:lumMod val="75000"/>
@@ -9424,7 +9328,7 @@
               </a:spcBef>
             </a:pPr>
             <a:r>
-              <a:rPr lang="en-US" sz="2100" dirty="0"/>
+              <a:rPr lang="en-US" sz="2100" noProof="0" dirty="0"/>
               <a:t>Do you resonate of having BMP and IPFIX data being transformed to YANG and integrated uniformly to Message Broker to ease data consumption for network operation and next generation AI applications?</a:t>
             </a:r>
           </a:p>
@@ -9435,7 +9339,7 @@
               </a:spcBef>
             </a:pPr>
             <a:r>
-              <a:rPr lang="en-US" sz="2100" dirty="0"/>
+              <a:rPr lang="en-US" sz="2100" noProof="0" dirty="0"/>
               <a:t>YANG-Push Message Broker integration has its home at NMOP, BMP at GROW and IPFIX at OPSAWG. Do you agree that having all Message Broker documents in NMOP regardless which Network Telemetry data is being collected and transformed would ease conformity?</a:t>
             </a:r>
           </a:p>
@@ -9446,300 +9350,72 @@
               </a:spcBef>
             </a:pPr>
             <a:r>
-              <a:rPr lang="en-US" sz="2100" dirty="0"/>
-              <a:t>The document introduces </a:t>
-            </a:r>
-            <a:r>
-              <a:rPr lang="de-CH" sz="2100" dirty="0"/>
-              <a:t>"</a:t>
-            </a:r>
-            <a:r>
-              <a:rPr lang="de-CH" sz="2100" dirty="0" err="1"/>
-              <a:t>ietf-bmp-bgp-rib-entry</a:t>
-            </a:r>
-            <a:r>
-              <a:rPr lang="de-CH" sz="2100" dirty="0"/>
-              <a:t>". </a:t>
-            </a:r>
-            <a:r>
-              <a:rPr lang="de-CH" sz="2100" dirty="0" err="1"/>
-              <a:t>Compared</a:t>
-            </a:r>
-            <a:r>
-              <a:rPr lang="de-CH" sz="2100" dirty="0"/>
-              <a:t> </a:t>
-            </a:r>
-            <a:r>
-              <a:rPr lang="de-CH" sz="2100" dirty="0" err="1"/>
-              <a:t>to</a:t>
-            </a:r>
-            <a:r>
-              <a:rPr lang="de-CH" sz="2100" dirty="0"/>
-              <a:t> "</a:t>
-            </a:r>
-            <a:r>
-              <a:rPr lang="de-CH" sz="2100" dirty="0" err="1"/>
-              <a:t>ietf-bgp-rib</a:t>
-            </a:r>
-            <a:r>
-              <a:rPr lang="de-CH" sz="2100" dirty="0"/>
-              <a:t>" </a:t>
-            </a:r>
-            <a:r>
-              <a:rPr lang="de-CH" sz="2100" dirty="0" err="1"/>
-              <a:t>that</a:t>
-            </a:r>
-            <a:r>
-              <a:rPr lang="de-CH" sz="2100" dirty="0"/>
-              <a:t> </a:t>
-            </a:r>
-            <a:r>
-              <a:rPr lang="de-CH" sz="2100" dirty="0" err="1"/>
-              <a:t>structure</a:t>
-            </a:r>
-            <a:r>
-              <a:rPr lang="de-CH" sz="2100" dirty="0"/>
-              <a:t> </a:t>
-            </a:r>
-            <a:r>
-              <a:rPr lang="de-CH" sz="2100" dirty="0" err="1"/>
-              <a:t>supports</a:t>
-            </a:r>
-            <a:r>
-              <a:rPr lang="de-CH" sz="2100" dirty="0"/>
-              <a:t> </a:t>
-            </a:r>
-            <a:r>
-              <a:rPr lang="de-CH" sz="2100" dirty="0" err="1"/>
-              <a:t>that</a:t>
-            </a:r>
-            <a:r>
-              <a:rPr lang="de-CH" sz="2100" dirty="0"/>
-              <a:t> </a:t>
-            </a:r>
-            <a:r>
-              <a:rPr lang="de-CH" sz="2100" dirty="0" err="1"/>
-              <a:t>each</a:t>
-            </a:r>
-            <a:r>
-              <a:rPr lang="de-CH" sz="2100" dirty="0"/>
-              <a:t> BGP </a:t>
-            </a:r>
-            <a:r>
-              <a:rPr lang="de-CH" sz="2100" dirty="0" err="1"/>
-              <a:t>path</a:t>
-            </a:r>
-            <a:r>
-              <a:rPr lang="de-CH" sz="2100" dirty="0"/>
-              <a:t> </a:t>
-            </a:r>
-            <a:r>
-              <a:rPr lang="de-CH" sz="2100" dirty="0" err="1"/>
-              <a:t>can</a:t>
-            </a:r>
-            <a:r>
-              <a:rPr lang="de-CH" sz="2100" dirty="0"/>
-              <a:t> </a:t>
-            </a:r>
-            <a:r>
-              <a:rPr lang="de-CH" sz="2100" dirty="0" err="1"/>
-              <a:t>be</a:t>
-            </a:r>
-            <a:r>
-              <a:rPr lang="de-CH" sz="2100" dirty="0"/>
-              <a:t> </a:t>
-            </a:r>
-            <a:r>
-              <a:rPr lang="de-CH" sz="2100" dirty="0" err="1"/>
-              <a:t>streamed</a:t>
-            </a:r>
-            <a:r>
-              <a:rPr lang="de-CH" sz="2100" dirty="0"/>
-              <a:t> </a:t>
-            </a:r>
-            <a:r>
-              <a:rPr lang="de-CH" sz="2100" dirty="0" err="1"/>
-              <a:t>individually</a:t>
-            </a:r>
-            <a:r>
-              <a:rPr lang="de-CH" sz="2100" dirty="0"/>
-              <a:t> </a:t>
-            </a:r>
-            <a:r>
-              <a:rPr lang="de-CH" sz="2100" dirty="0" err="1"/>
-              <a:t>or</a:t>
-            </a:r>
-            <a:r>
-              <a:rPr lang="de-CH" sz="2100" dirty="0"/>
-              <a:t> </a:t>
-            </a:r>
-            <a:r>
-              <a:rPr lang="de-CH" sz="2100" dirty="0" err="1"/>
-              <a:t>as</a:t>
-            </a:r>
-            <a:r>
-              <a:rPr lang="de-CH" sz="2100" dirty="0"/>
-              <a:t> JSON </a:t>
-            </a:r>
-            <a:r>
-              <a:rPr lang="de-CH" sz="2100" dirty="0" err="1"/>
-              <a:t>array</a:t>
-            </a:r>
-            <a:r>
-              <a:rPr lang="de-CH" sz="2100" dirty="0"/>
-              <a:t> in a </a:t>
-            </a:r>
-            <a:r>
-              <a:rPr lang="de-CH" sz="2100" dirty="0" err="1"/>
-              <a:t>message</a:t>
-            </a:r>
-            <a:r>
-              <a:rPr lang="de-CH" sz="2100" dirty="0"/>
-              <a:t> </a:t>
-            </a:r>
-            <a:r>
-              <a:rPr lang="de-CH" sz="2100" dirty="0" err="1"/>
-              <a:t>broker</a:t>
-            </a:r>
-            <a:r>
-              <a:rPr lang="de-CH" sz="2100" dirty="0"/>
-              <a:t> </a:t>
-            </a:r>
-            <a:r>
-              <a:rPr lang="de-CH" sz="2100" dirty="0" err="1"/>
-              <a:t>message</a:t>
-            </a:r>
-            <a:r>
-              <a:rPr lang="de-CH" sz="2100" dirty="0"/>
-              <a:t>. Do </a:t>
-            </a:r>
-            <a:r>
-              <a:rPr lang="de-CH" sz="2100" dirty="0" err="1"/>
-              <a:t>you</a:t>
-            </a:r>
-            <a:r>
-              <a:rPr lang="de-CH" sz="2100" dirty="0"/>
-              <a:t> </a:t>
-            </a:r>
-            <a:r>
-              <a:rPr lang="de-CH" sz="2100" dirty="0" err="1"/>
-              <a:t>agree</a:t>
-            </a:r>
-            <a:r>
-              <a:rPr lang="de-CH" sz="2100" dirty="0"/>
-              <a:t> </a:t>
-            </a:r>
-            <a:r>
-              <a:rPr lang="de-CH" sz="2100" dirty="0" err="1"/>
-              <a:t>that</a:t>
-            </a:r>
-            <a:r>
-              <a:rPr lang="de-CH" sz="2100" dirty="0"/>
-              <a:t> </a:t>
-            </a:r>
-            <a:r>
-              <a:rPr lang="de-CH" sz="2100" dirty="0" err="1"/>
-              <a:t>this</a:t>
-            </a:r>
-            <a:r>
-              <a:rPr lang="de-CH" sz="2100" dirty="0"/>
-              <a:t> </a:t>
-            </a:r>
-            <a:r>
-              <a:rPr lang="de-CH" sz="2100" dirty="0" err="1"/>
-              <a:t>should</a:t>
-            </a:r>
-            <a:r>
-              <a:rPr lang="de-CH" sz="2100" dirty="0"/>
-              <a:t> </a:t>
-            </a:r>
-            <a:r>
-              <a:rPr lang="de-CH" sz="2100" dirty="0" err="1"/>
-              <a:t>be</a:t>
-            </a:r>
-            <a:r>
-              <a:rPr lang="de-CH" sz="2100" dirty="0"/>
-              <a:t> </a:t>
-            </a:r>
-            <a:r>
-              <a:rPr lang="de-CH" sz="2100" dirty="0" err="1"/>
-              <a:t>defined</a:t>
-            </a:r>
-            <a:r>
-              <a:rPr lang="de-CH" sz="2100" dirty="0"/>
-              <a:t> in </a:t>
-            </a:r>
-            <a:r>
-              <a:rPr lang="de-CH" sz="2100" dirty="0" err="1"/>
-              <a:t>this</a:t>
-            </a:r>
-            <a:r>
-              <a:rPr lang="de-CH" sz="2100" dirty="0"/>
-              <a:t> </a:t>
-            </a:r>
-            <a:r>
-              <a:rPr lang="de-CH" sz="2100" dirty="0" err="1"/>
-              <a:t>document</a:t>
-            </a:r>
-            <a:r>
-              <a:rPr lang="de-CH" sz="2100" dirty="0"/>
-              <a:t> and </a:t>
-            </a:r>
-            <a:r>
-              <a:rPr lang="de-CH" sz="2100" dirty="0" err="1"/>
-              <a:t>groupings</a:t>
-            </a:r>
-            <a:r>
-              <a:rPr lang="de-CH" sz="2100" dirty="0"/>
-              <a:t> </a:t>
-            </a:r>
-            <a:r>
-              <a:rPr lang="de-CH" sz="2100" dirty="0" err="1"/>
-              <a:t>reused</a:t>
-            </a:r>
-            <a:r>
-              <a:rPr lang="de-CH" sz="2100" dirty="0"/>
-              <a:t> </a:t>
-            </a:r>
-            <a:r>
-              <a:rPr lang="de-CH" sz="2100" dirty="0" err="1"/>
-              <a:t>from</a:t>
-            </a:r>
-            <a:r>
-              <a:rPr lang="de-CH" sz="2100" dirty="0"/>
-              <a:t> "</a:t>
-            </a:r>
-            <a:r>
-              <a:rPr lang="de-CH" sz="2100" dirty="0" err="1"/>
+              <a:rPr lang="en-US" sz="2100" noProof="0" dirty="0"/>
+              <a:t>The document introduces "</a:t>
+            </a:r>
+            <a:r>
+              <a:rPr lang="en-US" sz="2100" noProof="0" dirty="0" err="1"/>
               <a:t>ietf</a:t>
             </a:r>
             <a:r>
-              <a:rPr lang="de-CH" sz="2100" dirty="0"/>
+              <a:rPr lang="en-US" sz="2100" noProof="0" dirty="0"/>
+              <a:t>-bmp-</a:t>
+            </a:r>
+            <a:r>
+              <a:rPr lang="en-US" sz="2100" noProof="0" dirty="0" err="1"/>
+              <a:t>bgp</a:t>
+            </a:r>
+            <a:r>
+              <a:rPr lang="en-US" sz="2100" noProof="0" dirty="0"/>
+              <a:t>-rib-entry". Compared to "</a:t>
+            </a:r>
+            <a:r>
+              <a:rPr lang="en-US" sz="2100" noProof="0" dirty="0" err="1"/>
+              <a:t>ietf</a:t>
+            </a:r>
+            <a:r>
+              <a:rPr lang="en-US" sz="2100" noProof="0" dirty="0"/>
               <a:t>-</a:t>
             </a:r>
             <a:r>
-              <a:rPr lang="de-CH" sz="2100" dirty="0" err="1"/>
+              <a:rPr lang="en-US" sz="2100" noProof="0" dirty="0" err="1"/>
               <a:t>bgp</a:t>
             </a:r>
             <a:r>
-              <a:rPr lang="de-CH" sz="2100" dirty="0"/>
+              <a:rPr lang="en-US" sz="2100" noProof="0" dirty="0"/>
+              <a:t>-rib" that structure supports that each BGP path can be streamed individually or as JSON array in a message broker message. Do you agree that this should be defined in this document and groupings reused from "</a:t>
+            </a:r>
+            <a:r>
+              <a:rPr lang="en-US" sz="2100" noProof="0" dirty="0" err="1"/>
+              <a:t>ietf</a:t>
+            </a:r>
+            <a:r>
+              <a:rPr lang="en-US" sz="2100" noProof="0" dirty="0"/>
               <a:t>-</a:t>
             </a:r>
             <a:r>
-              <a:rPr lang="de-CH" sz="2100" dirty="0" err="1"/>
-              <a:t>rib</a:t>
-            </a:r>
-            <a:r>
-              <a:rPr lang="de-CH" sz="2100" dirty="0"/>
-              <a:t>-attributes" and "</a:t>
-            </a:r>
-            <a:r>
-              <a:rPr lang="de-CH" sz="2100" dirty="0" err="1"/>
-              <a:t>ietf-bgp-rib-tables</a:t>
-            </a:r>
-            <a:r>
-              <a:rPr lang="de-CH" sz="2100" dirty="0"/>
-              <a:t>"?</a:t>
+              <a:rPr lang="en-US" sz="2100" noProof="0" dirty="0" err="1"/>
+              <a:t>bgp</a:t>
+            </a:r>
+            <a:r>
+              <a:rPr lang="en-US" sz="2100" noProof="0" dirty="0"/>
+              <a:t>-rib-attributes" and "</a:t>
+            </a:r>
+            <a:r>
+              <a:rPr lang="en-US" sz="2100" noProof="0" dirty="0" err="1"/>
+              <a:t>ietf</a:t>
+            </a:r>
+            <a:r>
+              <a:rPr lang="en-US" sz="2100" noProof="0" dirty="0"/>
+              <a:t>-</a:t>
+            </a:r>
+            <a:r>
+              <a:rPr lang="en-US" sz="2100" noProof="0" dirty="0" err="1"/>
+              <a:t>bgp</a:t>
+            </a:r>
+            <a:r>
+              <a:rPr lang="en-US" sz="2100" noProof="0" dirty="0"/>
+              <a:t>-rib-tables"?</a:t>
             </a:r>
           </a:p>
         </p:txBody>
@@ -9771,10 +9447,10 @@
           <a:lstStyle/>
           <a:p>
             <a:fld id="{FC4AC485-25DE-431E-B345-9C0A15BB7F8A}" type="slidenum">
-              <a:rPr lang="en-US" sz="1400" smtClean="0"/>
+              <a:rPr lang="en-US" sz="1400" noProof="0" smtClean="0"/>
               <a:t>16</a:t>
             </a:fld>
-            <a:endParaRPr lang="en-US" sz="1400" dirty="0"/>
+            <a:endParaRPr lang="en-US" sz="1400" noProof="0" dirty="0"/>
           </a:p>
         </p:txBody>
       </p:sp>
@@ -13879,7 +13555,7 @@
         </p:nvSpPr>
         <p:spPr>
           <a:xfrm>
-            <a:off x="838200" y="365125"/>
+            <a:off x="838200" y="382210"/>
             <a:ext cx="10515600" cy="1325563"/>
           </a:xfrm>
         </p:spPr>

</xml_diff>